<commit_message>
feat(slide): allineamento alla dispensa — +5 slide
Aggiunte 5 slide per coprire argomenti presenti nella dispensa
ma mancanti nelle slide:

L3 (14 → 15): UNION SELECT — slide dedicata con esempio payload
   completo (xyz' UNION SELECT email || ':' || password ...)
   e impatto concreto (estrazione completa password DB)

L4 (14 → 15): Caso reale italiano €100k — slide dedicata con
   provvedimento Garante 2022 contro e-commerce italiano
   (URL /ordine/<id> non protetti, GDPR Art. 25 + 32)

L5 (14 → 16): +2 slide
   - Storia di apertura "il commento rilanciato" (storytelling
     che era nella dispensa Cap 5)
   - bleach con esempio: sanitization HTML voluta dall'utente
     (commenti con grassetto/corsivo/link)

L6 (14 → 15): SBOM + Cyber Resilience Act 2027 — slide dedicata
   con scadenza dicembre 2027, formati CycloneDX/SPDX,
   sanzioni fino a 15M€

Totale slide del corso: 110 → 117 slide.

Co-Authored-By: Claude Opus 4.7 <noreply@anthropic.com>
</commit_message>
<xml_diff>
--- a/docx/slide/L6_validation_supply.pptx
+++ b/docx/slide/L6_validation_supply.pptx
@@ -19,6 +19,7 @@
     <p:sldId id="267" r:id="rId18"/>
     <p:sldId id="268" r:id="rId19"/>
     <p:sldId id="269" r:id="rId20"/>
+    <p:sldId id="270" r:id="rId21"/>
   </p:sldIdLst>
   <p:sldSz cx="12191695" cy="6858000" type="screen4x3"/>
   <p:notesSz cx="6858000" cy="9144000"/>
@@ -3966,7 +3967,7 @@
                 </a:solidFill>
                 <a:latin typeface="Calibri"/>
               </a:rPr>
-              <a:t>L6  ·  10/14</a:t>
+              <a:t>L6  ·  10/15</a:t>
             </a:r>
           </a:p>
         </p:txBody>
@@ -4414,7 +4415,7 @@
                 </a:solidFill>
                 <a:latin typeface="Calibri"/>
               </a:rPr>
-              <a:t>L6  ·  11/14</a:t>
+              <a:t>L6  ·  11/15</a:t>
             </a:r>
           </a:p>
         </p:txBody>
@@ -4674,7 +4675,7 @@
                 </a:solidFill>
                 <a:latin typeface="Calibri"/>
               </a:rPr>
-              <a:t>L6  ·  12/14</a:t>
+              <a:t>L6  ·  12/15</a:t>
             </a:r>
           </a:p>
         </p:txBody>
@@ -4770,51 +4771,43 @@
                 </a:solidFill>
                 <a:latin typeface="Calibri"/>
               </a:rPr>
-              <a:t>📌  Cosa portare a casa</a:t>
-            </a:r>
-          </a:p>
-        </p:txBody>
-      </p:sp>
-      <p:sp>
-        <p:nvSpPr>
-          <p:cNvPr id="4" name="Oval 3"/>
-          <p:cNvSpPr/>
-          <p:nvPr/>
-        </p:nvSpPr>
-        <p:spPr>
-          <a:xfrm>
-            <a:off x="914400" y="1440180"/>
-            <a:ext cx="777240" cy="777240"/>
-          </a:xfrm>
-          <a:prstGeom prst="ellipse">
-            <a:avLst/>
-          </a:prstGeom>
-          <a:solidFill>
-            <a:srgbClr val="00A0B0"/>
-          </a:solidFill>
-          <a:ln>
-            <a:noFill/>
-          </a:ln>
-        </p:spPr>
-        <p:style>
-          <a:lnRef idx="1">
-            <a:schemeClr val="accent1"/>
-          </a:lnRef>
-          <a:fillRef idx="3">
-            <a:schemeClr val="accent1"/>
-          </a:fillRef>
-          <a:effectRef idx="2">
-            <a:schemeClr val="accent1"/>
-          </a:effectRef>
-          <a:fontRef idx="minor">
-            <a:schemeClr val="lt1"/>
-          </a:fontRef>
-        </p:style>
-        <p:txBody>
-          <a:bodyPr rtlCol="0" anchor="ctr"/>
-          <a:lstStyle/>
-          <a:p>
-            <a:pPr algn="ctr"/>
+              <a:t>📜  SBOM e Cyber Resilience Act (dicembre 2027)</a:t>
+            </a:r>
+          </a:p>
+        </p:txBody>
+      </p:sp>
+      <p:sp>
+        <p:nvSpPr>
+          <p:cNvPr id="4" name="TextBox 3"/>
+          <p:cNvSpPr txBox="1"/>
+          <p:nvPr/>
+        </p:nvSpPr>
+        <p:spPr>
+          <a:xfrm>
+            <a:off x="457200" y="914400"/>
+            <a:ext cx="11247120" cy="457200"/>
+          </a:xfrm>
+          <a:prstGeom prst="rect">
+            <a:avLst/>
+          </a:prstGeom>
+          <a:noFill/>
+        </p:spPr>
+        <p:txBody>
+          <a:bodyPr wrap="square" lIns="45720" rIns="45720" tIns="18288" bIns="18288" anchor="t">
+            <a:spAutoFit/>
+          </a:bodyPr>
+          <a:lstStyle/>
+          <a:p>
+            <a:pPr algn="l"/>
+            <a:r>
+              <a:rPr sz="1500" b="0" i="1">
+                <a:solidFill>
+                  <a:srgbClr val="00A0B0"/>
+                </a:solidFill>
+                <a:latin typeface="Calibri"/>
+              </a:rPr>
+              <a:t>Iniziate a familiarizzare con pip-audit e cyclonedx-bom ADESSO</a:t>
+            </a:r>
           </a:p>
         </p:txBody>
       </p:sp>
@@ -4826,8 +4819,8 @@
         </p:nvSpPr>
         <p:spPr>
           <a:xfrm>
-            <a:off x="914400" y="1440180"/>
-            <a:ext cx="777240" cy="777240"/>
+            <a:off x="640080" y="1554480"/>
+            <a:ext cx="10972800" cy="5029200"/>
           </a:xfrm>
           <a:prstGeom prst="rect">
             <a:avLst/>
@@ -4835,749 +4828,323 @@
           <a:noFill/>
         </p:spPr>
         <p:txBody>
-          <a:bodyPr wrap="square" lIns="45720" rIns="45720" tIns="18288" bIns="18288" anchor="ctr">
+          <a:bodyPr wrap="square">
             <a:spAutoFit/>
           </a:bodyPr>
           <a:lstStyle/>
           <a:p>
-            <a:pPr algn="ctr"/>
-            <a:r>
-              <a:rPr sz="2800" b="1" i="0">
-                <a:solidFill>
-                  <a:srgbClr val="FFFFFF"/>
-                </a:solidFill>
-                <a:latin typeface="Calibri"/>
-              </a:rPr>
-              <a:t>1</a:t>
-            </a:r>
-          </a:p>
-        </p:txBody>
-      </p:sp>
-      <p:sp>
-        <p:nvSpPr>
-          <p:cNvPr id="6" name="Rounded Rectangle 5"/>
-          <p:cNvSpPr/>
-          <p:nvPr/>
-        </p:nvSpPr>
-        <p:spPr>
-          <a:xfrm>
-            <a:off x="2011680" y="1440180"/>
-            <a:ext cx="9144000" cy="777240"/>
-          </a:xfrm>
-          <a:prstGeom prst="roundRect">
-            <a:avLst>
-              <a:gd name="adj" fmla="val 8000"/>
-            </a:avLst>
-          </a:prstGeom>
-          <a:solidFill>
-            <a:srgbClr val="FBFBFD"/>
-          </a:solidFill>
-          <a:ln w="19050">
-            <a:solidFill>
-              <a:srgbClr val="00A0B0"/>
-            </a:solidFill>
-          </a:ln>
-        </p:spPr>
-        <p:style>
-          <a:lnRef idx="1">
-            <a:schemeClr val="accent1"/>
-          </a:lnRef>
-          <a:fillRef idx="3">
-            <a:schemeClr val="accent1"/>
-          </a:fillRef>
-          <a:effectRef idx="2">
-            <a:schemeClr val="accent1"/>
-          </a:effectRef>
-          <a:fontRef idx="minor">
-            <a:schemeClr val="lt1"/>
-          </a:fontRef>
-        </p:style>
-        <p:txBody>
-          <a:bodyPr rtlCol="0" anchor="ctr"/>
-          <a:lstStyle/>
-          <a:p>
-            <a:pPr algn="ctr"/>
-          </a:p>
-        </p:txBody>
-      </p:sp>
-      <p:sp>
-        <p:nvSpPr>
-          <p:cNvPr id="7" name="TextBox 6"/>
-          <p:cNvSpPr txBox="1"/>
-          <p:nvPr/>
-        </p:nvSpPr>
-        <p:spPr>
-          <a:xfrm>
-            <a:off x="2286000" y="1440180"/>
-            <a:ext cx="8686800" cy="777240"/>
-          </a:xfrm>
-          <a:prstGeom prst="rect">
-            <a:avLst/>
-          </a:prstGeom>
-          <a:noFill/>
-        </p:spPr>
-        <p:txBody>
-          <a:bodyPr wrap="square" lIns="45720" rIns="45720" tIns="18288" bIns="18288" anchor="ctr">
-            <a:spAutoFit/>
-          </a:bodyPr>
-          <a:lstStyle/>
-          <a:p>
-            <a:pPr algn="l"/>
-            <a:r>
-              <a:rPr sz="1800" b="0" i="0">
+            <a:pPr>
+              <a:lnSpc>
+                <a:spcPct val="150000"/>
+              </a:lnSpc>
+              <a:spcAft>
+                <a:spcPts val="400"/>
+              </a:spcAft>
+            </a:pPr>
+            <a:r>
+              <a:rPr sz="2000" b="1">
+                <a:solidFill>
+                  <a:srgbClr val="00A0B0"/>
+                </a:solidFill>
+                <a:latin typeface="Calibri"/>
+              </a:rPr>
+              <a:t>▸  </a:t>
+            </a:r>
+            <a:r>
+              <a:rPr sz="2000">
                 <a:solidFill>
                   <a:srgbClr val="1A1A2E"/>
                 </a:solidFill>
                 <a:latin typeface="Calibri"/>
               </a:rPr>
-              <a:t>Validation, sanitization, encoding: cose DIVERSE</a:t>
-            </a:r>
-          </a:p>
-        </p:txBody>
-      </p:sp>
-      <p:sp>
-        <p:nvSpPr>
-          <p:cNvPr id="8" name="Oval 7"/>
-          <p:cNvSpPr/>
-          <p:nvPr/>
-        </p:nvSpPr>
-        <p:spPr>
-          <a:xfrm>
-            <a:off x="914400" y="2354580"/>
-            <a:ext cx="777240" cy="777240"/>
-          </a:xfrm>
-          <a:prstGeom prst="ellipse">
-            <a:avLst/>
-          </a:prstGeom>
-          <a:solidFill>
-            <a:srgbClr val="00A0B0"/>
-          </a:solidFill>
-          <a:ln>
-            <a:noFill/>
-          </a:ln>
-        </p:spPr>
-        <p:style>
-          <a:lnRef idx="1">
-            <a:schemeClr val="accent1"/>
-          </a:lnRef>
-          <a:fillRef idx="3">
-            <a:schemeClr val="accent1"/>
-          </a:fillRef>
-          <a:effectRef idx="2">
-            <a:schemeClr val="accent1"/>
-          </a:effectRef>
-          <a:fontRef idx="minor">
-            <a:schemeClr val="lt1"/>
-          </a:fontRef>
-        </p:style>
-        <p:txBody>
-          <a:bodyPr rtlCol="0" anchor="ctr"/>
-          <a:lstStyle/>
-          <a:p>
-            <a:pPr algn="ctr"/>
-          </a:p>
-        </p:txBody>
-      </p:sp>
-      <p:sp>
-        <p:nvSpPr>
-          <p:cNvPr id="9" name="TextBox 8"/>
-          <p:cNvSpPr txBox="1"/>
-          <p:nvPr/>
-        </p:nvSpPr>
-        <p:spPr>
-          <a:xfrm>
-            <a:off x="914400" y="2354580"/>
-            <a:ext cx="777240" cy="777240"/>
-          </a:xfrm>
-          <a:prstGeom prst="rect">
-            <a:avLst/>
-          </a:prstGeom>
-          <a:noFill/>
-        </p:spPr>
-        <p:txBody>
-          <a:bodyPr wrap="square" lIns="45720" rIns="45720" tIns="18288" bIns="18288" anchor="ctr">
-            <a:spAutoFit/>
-          </a:bodyPr>
-          <a:lstStyle/>
-          <a:p>
-            <a:pPr algn="ctr"/>
-            <a:r>
-              <a:rPr sz="2800" b="1" i="0">
-                <a:solidFill>
-                  <a:srgbClr val="FFFFFF"/>
-                </a:solidFill>
-                <a:latin typeface="Calibri"/>
-              </a:rPr>
-              <a:t>2</a:t>
-            </a:r>
-          </a:p>
-        </p:txBody>
-      </p:sp>
-      <p:sp>
-        <p:nvSpPr>
-          <p:cNvPr id="10" name="Rounded Rectangle 9"/>
-          <p:cNvSpPr/>
-          <p:nvPr/>
-        </p:nvSpPr>
-        <p:spPr>
-          <a:xfrm>
-            <a:off x="2011680" y="2354580"/>
-            <a:ext cx="9144000" cy="777240"/>
-          </a:xfrm>
-          <a:prstGeom prst="roundRect">
-            <a:avLst>
-              <a:gd name="adj" fmla="val 8000"/>
-            </a:avLst>
-          </a:prstGeom>
-          <a:solidFill>
-            <a:srgbClr val="FBFBFD"/>
-          </a:solidFill>
-          <a:ln w="19050">
-            <a:solidFill>
-              <a:srgbClr val="00A0B0"/>
-            </a:solidFill>
-          </a:ln>
-        </p:spPr>
-        <p:style>
-          <a:lnRef idx="1">
-            <a:schemeClr val="accent1"/>
-          </a:lnRef>
-          <a:fillRef idx="3">
-            <a:schemeClr val="accent1"/>
-          </a:fillRef>
-          <a:effectRef idx="2">
-            <a:schemeClr val="accent1"/>
-          </a:effectRef>
-          <a:fontRef idx="minor">
-            <a:schemeClr val="lt1"/>
-          </a:fontRef>
-        </p:style>
-        <p:txBody>
-          <a:bodyPr rtlCol="0" anchor="ctr"/>
-          <a:lstStyle/>
-          <a:p>
-            <a:pPr algn="ctr"/>
-          </a:p>
-        </p:txBody>
-      </p:sp>
-      <p:sp>
-        <p:nvSpPr>
-          <p:cNvPr id="11" name="TextBox 10"/>
-          <p:cNvSpPr txBox="1"/>
-          <p:nvPr/>
-        </p:nvSpPr>
-        <p:spPr>
-          <a:xfrm>
-            <a:off x="2286000" y="2354580"/>
-            <a:ext cx="8686800" cy="777240"/>
-          </a:xfrm>
-          <a:prstGeom prst="rect">
-            <a:avLst/>
-          </a:prstGeom>
-          <a:noFill/>
-        </p:spPr>
-        <p:txBody>
-          <a:bodyPr wrap="square" lIns="45720" rIns="45720" tIns="18288" bIns="18288" anchor="ctr">
-            <a:spAutoFit/>
-          </a:bodyPr>
-          <a:lstStyle/>
-          <a:p>
-            <a:pPr algn="l"/>
-            <a:r>
-              <a:rPr sz="1800" b="0" i="0">
+              <a:t>SBOM = Software Bill of Materials</a:t>
+            </a:r>
+          </a:p>
+          <a:p>
+            <a:pPr>
+              <a:lnSpc>
+                <a:spcPct val="150000"/>
+              </a:lnSpc>
+              <a:spcAft>
+                <a:spcPts val="400"/>
+              </a:spcAft>
+            </a:pPr>
+            <a:r>
+              <a:rPr sz="2000" b="1">
+                <a:solidFill>
+                  <a:srgbClr val="00A0B0"/>
+                </a:solidFill>
+                <a:latin typeface="Calibri"/>
+              </a:rPr>
+              <a:t>▸  </a:t>
+            </a:r>
+            <a:r>
+              <a:rPr sz="2000">
                 <a:solidFill>
                   <a:srgbClr val="1A1A2E"/>
                 </a:solidFill>
                 <a:latin typeface="Calibri"/>
               </a:rPr>
-              <a:t>Whitelist sempre. Blacklist mai.</a:t>
-            </a:r>
-          </a:p>
-        </p:txBody>
-      </p:sp>
-      <p:sp>
-        <p:nvSpPr>
-          <p:cNvPr id="12" name="Oval 11"/>
-          <p:cNvSpPr/>
-          <p:nvPr/>
-        </p:nvSpPr>
-        <p:spPr>
-          <a:xfrm>
-            <a:off x="914400" y="3268980"/>
-            <a:ext cx="777240" cy="777240"/>
-          </a:xfrm>
-          <a:prstGeom prst="ellipse">
-            <a:avLst/>
-          </a:prstGeom>
-          <a:solidFill>
-            <a:srgbClr val="00A0B0"/>
-          </a:solidFill>
-          <a:ln>
-            <a:noFill/>
-          </a:ln>
-        </p:spPr>
-        <p:style>
-          <a:lnRef idx="1">
-            <a:schemeClr val="accent1"/>
-          </a:lnRef>
-          <a:fillRef idx="3">
-            <a:schemeClr val="accent1"/>
-          </a:fillRef>
-          <a:effectRef idx="2">
-            <a:schemeClr val="accent1"/>
-          </a:effectRef>
-          <a:fontRef idx="minor">
-            <a:schemeClr val="lt1"/>
-          </a:fontRef>
-        </p:style>
-        <p:txBody>
-          <a:bodyPr rtlCol="0" anchor="ctr"/>
-          <a:lstStyle/>
-          <a:p>
-            <a:pPr algn="ctr"/>
-          </a:p>
-        </p:txBody>
-      </p:sp>
-      <p:sp>
-        <p:nvSpPr>
-          <p:cNvPr id="13" name="TextBox 12"/>
-          <p:cNvSpPr txBox="1"/>
-          <p:nvPr/>
-        </p:nvSpPr>
-        <p:spPr>
-          <a:xfrm>
-            <a:off x="914400" y="3268980"/>
-            <a:ext cx="777240" cy="777240"/>
-          </a:xfrm>
-          <a:prstGeom prst="rect">
-            <a:avLst/>
-          </a:prstGeom>
-          <a:noFill/>
-        </p:spPr>
-        <p:txBody>
-          <a:bodyPr wrap="square" lIns="45720" rIns="45720" tIns="18288" bIns="18288" anchor="ctr">
-            <a:spAutoFit/>
-          </a:bodyPr>
-          <a:lstStyle/>
-          <a:p>
-            <a:pPr algn="ctr"/>
-            <a:r>
-              <a:rPr sz="2800" b="1" i="0">
-                <a:solidFill>
-                  <a:srgbClr val="FFFFFF"/>
-                </a:solidFill>
-                <a:latin typeface="Calibri"/>
-              </a:rPr>
-              <a:t>3</a:t>
-            </a:r>
-          </a:p>
-        </p:txBody>
-      </p:sp>
-      <p:sp>
-        <p:nvSpPr>
-          <p:cNvPr id="14" name="Rounded Rectangle 13"/>
-          <p:cNvSpPr/>
-          <p:nvPr/>
-        </p:nvSpPr>
-        <p:spPr>
-          <a:xfrm>
-            <a:off x="2011680" y="3268980"/>
-            <a:ext cx="9144000" cy="777240"/>
-          </a:xfrm>
-          <a:prstGeom prst="roundRect">
-            <a:avLst>
-              <a:gd name="adj" fmla="val 8000"/>
-            </a:avLst>
-          </a:prstGeom>
-          <a:solidFill>
-            <a:srgbClr val="FBFBFD"/>
-          </a:solidFill>
-          <a:ln w="19050">
-            <a:solidFill>
-              <a:srgbClr val="00A0B0"/>
-            </a:solidFill>
-          </a:ln>
-        </p:spPr>
-        <p:style>
-          <a:lnRef idx="1">
-            <a:schemeClr val="accent1"/>
-          </a:lnRef>
-          <a:fillRef idx="3">
-            <a:schemeClr val="accent1"/>
-          </a:fillRef>
-          <a:effectRef idx="2">
-            <a:schemeClr val="accent1"/>
-          </a:effectRef>
-          <a:fontRef idx="minor">
-            <a:schemeClr val="lt1"/>
-          </a:fontRef>
-        </p:style>
-        <p:txBody>
-          <a:bodyPr rtlCol="0" anchor="ctr"/>
-          <a:lstStyle/>
-          <a:p>
-            <a:pPr algn="ctr"/>
-          </a:p>
-        </p:txBody>
-      </p:sp>
-      <p:sp>
-        <p:nvSpPr>
-          <p:cNvPr id="15" name="TextBox 14"/>
-          <p:cNvSpPr txBox="1"/>
-          <p:nvPr/>
-        </p:nvSpPr>
-        <p:spPr>
-          <a:xfrm>
-            <a:off x="2286000" y="3268980"/>
-            <a:ext cx="8686800" cy="777240"/>
-          </a:xfrm>
-          <a:prstGeom prst="rect">
-            <a:avLst/>
-          </a:prstGeom>
-          <a:noFill/>
-        </p:spPr>
-        <p:txBody>
-          <a:bodyPr wrap="square" lIns="45720" rIns="45720" tIns="18288" bIns="18288" anchor="ctr">
-            <a:spAutoFit/>
-          </a:bodyPr>
-          <a:lstStyle/>
-          <a:p>
-            <a:pPr algn="l"/>
-            <a:r>
-              <a:rPr sz="1800" b="0" i="0">
+              <a:t>  Lista completa delle dipendenze del prodotto (versioni, hash)</a:t>
+            </a:r>
+          </a:p>
+          <a:p>
+            <a:pPr>
+              <a:lnSpc>
+                <a:spcPct val="150000"/>
+              </a:lnSpc>
+              <a:spcAft>
+                <a:spcPts val="400"/>
+              </a:spcAft>
+            </a:pPr>
+            <a:r>
+              <a:rPr sz="2000" b="1">
+                <a:solidFill>
+                  <a:srgbClr val="00A0B0"/>
+                </a:solidFill>
+                <a:latin typeface="Calibri"/>
+              </a:rPr>
+              <a:t>▸  </a:t>
+            </a:r>
+            <a:r>
+              <a:rPr sz="2000">
                 <a:solidFill>
                   <a:srgbClr val="1A1A2E"/>
                 </a:solidFill>
                 <a:latin typeface="Calibri"/>
               </a:rPr>
-              <a:t>Pydantic per validation strutturata in Python</a:t>
-            </a:r>
-          </a:p>
-        </p:txBody>
-      </p:sp>
-      <p:sp>
-        <p:nvSpPr>
-          <p:cNvPr id="16" name="Oval 15"/>
-          <p:cNvSpPr/>
-          <p:nvPr/>
-        </p:nvSpPr>
-        <p:spPr>
-          <a:xfrm>
-            <a:off x="914400" y="4183380"/>
-            <a:ext cx="777240" cy="777240"/>
-          </a:xfrm>
-          <a:prstGeom prst="ellipse">
-            <a:avLst/>
-          </a:prstGeom>
-          <a:solidFill>
-            <a:srgbClr val="00A0B0"/>
-          </a:solidFill>
-          <a:ln>
-            <a:noFill/>
-          </a:ln>
-        </p:spPr>
-        <p:style>
-          <a:lnRef idx="1">
-            <a:schemeClr val="accent1"/>
-          </a:lnRef>
-          <a:fillRef idx="3">
-            <a:schemeClr val="accent1"/>
-          </a:fillRef>
-          <a:effectRef idx="2">
-            <a:schemeClr val="accent1"/>
-          </a:effectRef>
-          <a:fontRef idx="minor">
-            <a:schemeClr val="lt1"/>
-          </a:fontRef>
-        </p:style>
-        <p:txBody>
-          <a:bodyPr rtlCol="0" anchor="ctr"/>
-          <a:lstStyle/>
-          <a:p>
-            <a:pPr algn="ctr"/>
-          </a:p>
-        </p:txBody>
-      </p:sp>
-      <p:sp>
-        <p:nvSpPr>
-          <p:cNvPr id="17" name="TextBox 16"/>
-          <p:cNvSpPr txBox="1"/>
-          <p:nvPr/>
-        </p:nvSpPr>
-        <p:spPr>
-          <a:xfrm>
-            <a:off x="914400" y="4183380"/>
-            <a:ext cx="777240" cy="777240"/>
-          </a:xfrm>
-          <a:prstGeom prst="rect">
-            <a:avLst/>
-          </a:prstGeom>
-          <a:noFill/>
-        </p:spPr>
-        <p:txBody>
-          <a:bodyPr wrap="square" lIns="45720" rIns="45720" tIns="18288" bIns="18288" anchor="ctr">
-            <a:spAutoFit/>
-          </a:bodyPr>
-          <a:lstStyle/>
-          <a:p>
-            <a:pPr algn="ctr"/>
-            <a:r>
-              <a:rPr sz="2800" b="1" i="0">
-                <a:solidFill>
-                  <a:srgbClr val="FFFFFF"/>
-                </a:solidFill>
-                <a:latin typeface="Calibri"/>
-              </a:rPr>
-              <a:t>4</a:t>
-            </a:r>
-          </a:p>
-        </p:txBody>
-      </p:sp>
-      <p:sp>
-        <p:nvSpPr>
-          <p:cNvPr id="18" name="Rounded Rectangle 17"/>
-          <p:cNvSpPr/>
-          <p:nvPr/>
-        </p:nvSpPr>
-        <p:spPr>
-          <a:xfrm>
-            <a:off x="2011680" y="4183380"/>
-            <a:ext cx="9144000" cy="777240"/>
-          </a:xfrm>
-          <a:prstGeom prst="roundRect">
-            <a:avLst>
-              <a:gd name="adj" fmla="val 8000"/>
-            </a:avLst>
-          </a:prstGeom>
-          <a:solidFill>
-            <a:srgbClr val="FBFBFD"/>
-          </a:solidFill>
-          <a:ln w="19050">
-            <a:solidFill>
-              <a:srgbClr val="00A0B0"/>
-            </a:solidFill>
-          </a:ln>
-        </p:spPr>
-        <p:style>
-          <a:lnRef idx="1">
-            <a:schemeClr val="accent1"/>
-          </a:lnRef>
-          <a:fillRef idx="3">
-            <a:schemeClr val="accent1"/>
-          </a:fillRef>
-          <a:effectRef idx="2">
-            <a:schemeClr val="accent1"/>
-          </a:effectRef>
-          <a:fontRef idx="minor">
-            <a:schemeClr val="lt1"/>
-          </a:fontRef>
-        </p:style>
-        <p:txBody>
-          <a:bodyPr rtlCol="0" anchor="ctr"/>
-          <a:lstStyle/>
-          <a:p>
-            <a:pPr algn="ctr"/>
-          </a:p>
-        </p:txBody>
-      </p:sp>
-      <p:sp>
-        <p:nvSpPr>
-          <p:cNvPr id="19" name="TextBox 18"/>
-          <p:cNvSpPr txBox="1"/>
-          <p:nvPr/>
-        </p:nvSpPr>
-        <p:spPr>
-          <a:xfrm>
-            <a:off x="2286000" y="4183380"/>
-            <a:ext cx="8686800" cy="777240"/>
-          </a:xfrm>
-          <a:prstGeom prst="rect">
-            <a:avLst/>
-          </a:prstGeom>
-          <a:noFill/>
-        </p:spPr>
-        <p:txBody>
-          <a:bodyPr wrap="square" lIns="45720" rIns="45720" tIns="18288" bIns="18288" anchor="ctr">
-            <a:spAutoFit/>
-          </a:bodyPr>
-          <a:lstStyle/>
-          <a:p>
-            <a:pPr algn="l"/>
-            <a:r>
-              <a:rPr sz="1800" b="0" i="0">
+              <a:t>  Formati: CycloneDX, SPDX</a:t>
+            </a:r>
+          </a:p>
+          <a:p>
+            <a:pPr>
+              <a:lnSpc>
+                <a:spcPct val="150000"/>
+              </a:lnSpc>
+              <a:spcAft>
+                <a:spcPts val="400"/>
+              </a:spcAft>
+            </a:pPr>
+            <a:r>
+              <a:rPr sz="2000" b="1">
+                <a:solidFill>
+                  <a:srgbClr val="00A0B0"/>
+                </a:solidFill>
+                <a:latin typeface="Calibri"/>
+              </a:rPr>
+              <a:t>▸  </a:t>
+            </a:r>
+            <a:r>
+              <a:rPr sz="2000">
                 <a:solidFill>
                   <a:srgbClr val="1A1A2E"/>
                 </a:solidFill>
                 <a:latin typeface="Calibri"/>
               </a:rPr>
-              <a:t>Path traversal: 3 controlli obbligatori (whitelist, ext, realpath)</a:t>
-            </a:r>
-          </a:p>
-        </p:txBody>
-      </p:sp>
-      <p:sp>
-        <p:nvSpPr>
-          <p:cNvPr id="20" name="Oval 19"/>
-          <p:cNvSpPr/>
-          <p:nvPr/>
-        </p:nvSpPr>
-        <p:spPr>
-          <a:xfrm>
-            <a:off x="914400" y="5097780"/>
-            <a:ext cx="777240" cy="777240"/>
-          </a:xfrm>
-          <a:prstGeom prst="ellipse">
-            <a:avLst/>
-          </a:prstGeom>
-          <a:solidFill>
-            <a:srgbClr val="00A0B0"/>
-          </a:solidFill>
-          <a:ln>
-            <a:noFill/>
-          </a:ln>
-        </p:spPr>
-        <p:style>
-          <a:lnRef idx="1">
-            <a:schemeClr val="accent1"/>
-          </a:lnRef>
-          <a:fillRef idx="3">
-            <a:schemeClr val="accent1"/>
-          </a:fillRef>
-          <a:effectRef idx="2">
-            <a:schemeClr val="accent1"/>
-          </a:effectRef>
-          <a:fontRef idx="minor">
-            <a:schemeClr val="lt1"/>
-          </a:fontRef>
-        </p:style>
-        <p:txBody>
-          <a:bodyPr rtlCol="0" anchor="ctr"/>
-          <a:lstStyle/>
-          <a:p>
-            <a:pPr algn="ctr"/>
-          </a:p>
-        </p:txBody>
-      </p:sp>
-      <p:sp>
-        <p:nvSpPr>
-          <p:cNvPr id="21" name="TextBox 20"/>
-          <p:cNvSpPr txBox="1"/>
-          <p:nvPr/>
-        </p:nvSpPr>
-        <p:spPr>
-          <a:xfrm>
-            <a:off x="914400" y="5097780"/>
-            <a:ext cx="777240" cy="777240"/>
-          </a:xfrm>
-          <a:prstGeom prst="rect">
-            <a:avLst/>
-          </a:prstGeom>
-          <a:noFill/>
-        </p:spPr>
-        <p:txBody>
-          <a:bodyPr wrap="square" lIns="45720" rIns="45720" tIns="18288" bIns="18288" anchor="ctr">
-            <a:spAutoFit/>
-          </a:bodyPr>
-          <a:lstStyle/>
-          <a:p>
-            <a:pPr algn="ctr"/>
-            <a:r>
-              <a:rPr sz="2800" b="1" i="0">
-                <a:solidFill>
-                  <a:srgbClr val="FFFFFF"/>
-                </a:solidFill>
-                <a:latin typeface="Calibri"/>
-              </a:rPr>
-              <a:t>5</a:t>
-            </a:r>
-          </a:p>
-        </p:txBody>
-      </p:sp>
-      <p:sp>
-        <p:nvSpPr>
-          <p:cNvPr id="22" name="Rounded Rectangle 21"/>
-          <p:cNvSpPr/>
-          <p:nvPr/>
-        </p:nvSpPr>
-        <p:spPr>
-          <a:xfrm>
-            <a:off x="2011680" y="5097780"/>
-            <a:ext cx="9144000" cy="777240"/>
-          </a:xfrm>
-          <a:prstGeom prst="roundRect">
-            <a:avLst>
-              <a:gd name="adj" fmla="val 8000"/>
-            </a:avLst>
-          </a:prstGeom>
-          <a:solidFill>
-            <a:srgbClr val="FBFBFD"/>
-          </a:solidFill>
-          <a:ln w="19050">
-            <a:solidFill>
-              <a:srgbClr val="00A0B0"/>
-            </a:solidFill>
-          </a:ln>
-        </p:spPr>
-        <p:style>
-          <a:lnRef idx="1">
-            <a:schemeClr val="accent1"/>
-          </a:lnRef>
-          <a:fillRef idx="3">
-            <a:schemeClr val="accent1"/>
-          </a:fillRef>
-          <a:effectRef idx="2">
-            <a:schemeClr val="accent1"/>
-          </a:effectRef>
-          <a:fontRef idx="minor">
-            <a:schemeClr val="lt1"/>
-          </a:fontRef>
-        </p:style>
-        <p:txBody>
-          <a:bodyPr rtlCol="0" anchor="ctr"/>
-          <a:lstStyle/>
-          <a:p>
-            <a:pPr algn="ctr"/>
-          </a:p>
-        </p:txBody>
-      </p:sp>
-      <p:sp>
-        <p:nvSpPr>
-          <p:cNvPr id="23" name="TextBox 22"/>
-          <p:cNvSpPr txBox="1"/>
-          <p:nvPr/>
-        </p:nvSpPr>
-        <p:spPr>
-          <a:xfrm>
-            <a:off x="2286000" y="5097780"/>
-            <a:ext cx="8686800" cy="777240"/>
-          </a:xfrm>
-          <a:prstGeom prst="rect">
-            <a:avLst/>
-          </a:prstGeom>
-          <a:noFill/>
-        </p:spPr>
-        <p:txBody>
-          <a:bodyPr wrap="square" lIns="45720" rIns="45720" tIns="18288" bIns="18288" anchor="ctr">
-            <a:spAutoFit/>
-          </a:bodyPr>
-          <a:lstStyle/>
-          <a:p>
-            <a:pPr algn="l"/>
-            <a:r>
-              <a:rPr sz="1800" b="0" i="0">
+              <a:t/>
+            </a:r>
+          </a:p>
+          <a:p>
+            <a:pPr>
+              <a:lnSpc>
+                <a:spcPct val="150000"/>
+              </a:lnSpc>
+              <a:spcAft>
+                <a:spcPts val="400"/>
+              </a:spcAft>
+            </a:pPr>
+            <a:r>
+              <a:rPr sz="2000" b="1">
+                <a:solidFill>
+                  <a:srgbClr val="00A0B0"/>
+                </a:solidFill>
+                <a:latin typeface="Calibri"/>
+              </a:rPr>
+              <a:t>▸  </a:t>
+            </a:r>
+            <a:r>
+              <a:rPr sz="2000">
                 <a:solidFill>
                   <a:srgbClr val="1A1A2E"/>
                 </a:solidFill>
                 <a:latin typeface="Calibri"/>
               </a:rPr>
-              <a:t>pip-audit in CI: blocca il deploy con CVE Critical</a:t>
+              <a:t>Cyber Resilience Act (Reg. UE 2024/2847):</a:t>
+            </a:r>
+          </a:p>
+          <a:p>
+            <a:pPr>
+              <a:lnSpc>
+                <a:spcPct val="150000"/>
+              </a:lnSpc>
+              <a:spcAft>
+                <a:spcPts val="400"/>
+              </a:spcAft>
+            </a:pPr>
+            <a:r>
+              <a:rPr sz="2000" b="1">
+                <a:solidFill>
+                  <a:srgbClr val="00A0B0"/>
+                </a:solidFill>
+                <a:latin typeface="Calibri"/>
+              </a:rPr>
+              <a:t>▸  </a:t>
+            </a:r>
+            <a:r>
+              <a:rPr sz="2000">
+                <a:solidFill>
+                  <a:srgbClr val="1A1A2E"/>
+                </a:solidFill>
+                <a:latin typeface="Calibri"/>
+              </a:rPr>
+              <a:t>  In vigore pieno: DICEMBRE 2027</a:t>
+            </a:r>
+          </a:p>
+          <a:p>
+            <a:pPr>
+              <a:lnSpc>
+                <a:spcPct val="150000"/>
+              </a:lnSpc>
+              <a:spcAft>
+                <a:spcPts val="400"/>
+              </a:spcAft>
+            </a:pPr>
+            <a:r>
+              <a:rPr sz="2000" b="1">
+                <a:solidFill>
+                  <a:srgbClr val="00A0B0"/>
+                </a:solidFill>
+                <a:latin typeface="Calibri"/>
+              </a:rPr>
+              <a:t>▸  </a:t>
+            </a:r>
+            <a:r>
+              <a:rPr sz="2000">
+                <a:solidFill>
+                  <a:srgbClr val="1A1A2E"/>
+                </a:solidFill>
+                <a:latin typeface="Calibri"/>
+              </a:rPr>
+              <a:t>  Per ogni 'prodotto digitale' venduto in UE</a:t>
+            </a:r>
+          </a:p>
+          <a:p>
+            <a:pPr>
+              <a:lnSpc>
+                <a:spcPct val="150000"/>
+              </a:lnSpc>
+              <a:spcAft>
+                <a:spcPts val="400"/>
+              </a:spcAft>
+            </a:pPr>
+            <a:r>
+              <a:rPr sz="2000" b="1">
+                <a:solidFill>
+                  <a:srgbClr val="00A0B0"/>
+                </a:solidFill>
+                <a:latin typeface="Calibri"/>
+              </a:rPr>
+              <a:t>▸  </a:t>
+            </a:r>
+            <a:r>
+              <a:rPr sz="2000">
+                <a:solidFill>
+                  <a:srgbClr val="1A1A2E"/>
+                </a:solidFill>
+                <a:latin typeface="Calibri"/>
+              </a:rPr>
+              <a:t/>
+            </a:r>
+          </a:p>
+          <a:p>
+            <a:pPr>
+              <a:lnSpc>
+                <a:spcPct val="150000"/>
+              </a:lnSpc>
+              <a:spcAft>
+                <a:spcPts val="400"/>
+              </a:spcAft>
+            </a:pPr>
+            <a:r>
+              <a:rPr sz="2000" b="1">
+                <a:solidFill>
+                  <a:srgbClr val="00A0B0"/>
+                </a:solidFill>
+                <a:latin typeface="Calibri"/>
+              </a:rPr>
+              <a:t>▸  </a:t>
+            </a:r>
+            <a:r>
+              <a:rPr sz="2000">
+                <a:solidFill>
+                  <a:srgbClr val="1A1A2E"/>
+                </a:solidFill>
+                <a:latin typeface="Calibri"/>
+              </a:rPr>
+              <a:t>Obblighi: SBOM pubblicato · niente CVE note alla vendita</a:t>
+            </a:r>
+          </a:p>
+          <a:p>
+            <a:pPr>
+              <a:lnSpc>
+                <a:spcPct val="150000"/>
+              </a:lnSpc>
+              <a:spcAft>
+                <a:spcPts val="400"/>
+              </a:spcAft>
+            </a:pPr>
+            <a:r>
+              <a:rPr sz="2000" b="1">
+                <a:solidFill>
+                  <a:srgbClr val="00A0B0"/>
+                </a:solidFill>
+                <a:latin typeface="Calibri"/>
+              </a:rPr>
+              <a:t>▸  </a:t>
+            </a:r>
+            <a:r>
+              <a:rPr sz="2000">
+                <a:solidFill>
+                  <a:srgbClr val="1A1A2E"/>
+                </a:solidFill>
+                <a:latin typeface="Calibri"/>
+              </a:rPr>
+              <a:t>         · patching ≥5 anni · notifica 24h vulnerabilità sfruttate</a:t>
+            </a:r>
+          </a:p>
+          <a:p>
+            <a:pPr>
+              <a:lnSpc>
+                <a:spcPct val="150000"/>
+              </a:lnSpc>
+              <a:spcAft>
+                <a:spcPts val="400"/>
+              </a:spcAft>
+            </a:pPr>
+            <a:r>
+              <a:rPr sz="2000" b="1">
+                <a:solidFill>
+                  <a:srgbClr val="00A0B0"/>
+                </a:solidFill>
+                <a:latin typeface="Calibri"/>
+              </a:rPr>
+              <a:t>▸  </a:t>
+            </a:r>
+            <a:r>
+              <a:rPr sz="2000">
+                <a:solidFill>
+                  <a:srgbClr val="1A1A2E"/>
+                </a:solidFill>
+                <a:latin typeface="Calibri"/>
+              </a:rPr>
+              <a:t>         · sanzioni fino a 15M€ o 2,5% fatturato</a:t>
             </a:r>
           </a:p>
         </p:txBody>
       </p:sp>
       <p:cxnSp>
         <p:nvCxnSpPr>
-          <p:cNvPr id="24" name="Connector 23"/>
+          <p:cNvPr id="6" name="Connector 5"/>
           <p:cNvCxnSpPr/>
           <p:nvPr/>
         </p:nvCxnSpPr>
@@ -5612,7 +5179,7 @@
       </p:cxnSp>
       <p:sp>
         <p:nvSpPr>
-          <p:cNvPr id="25" name="TextBox 24"/>
+          <p:cNvPr id="7" name="TextBox 6"/>
           <p:cNvSpPr txBox="1"/>
           <p:nvPr/>
         </p:nvSpPr>
@@ -5647,7 +5214,7 @@
       </p:sp>
       <p:sp>
         <p:nvSpPr>
-          <p:cNvPr id="26" name="TextBox 25"/>
+          <p:cNvPr id="8" name="TextBox 7"/>
           <p:cNvSpPr txBox="1"/>
           <p:nvPr/>
         </p:nvSpPr>
@@ -5675,7 +5242,7 @@
                 </a:solidFill>
                 <a:latin typeface="Calibri"/>
               </a:rPr>
-              <a:t>L6  ·  13/14</a:t>
+              <a:t>L6  ·  13/15</a:t>
             </a:r>
           </a:p>
         </p:txBody>
@@ -5707,6 +5274,1007 @@
         <p:spPr>
           <a:xfrm>
             <a:off x="0" y="0"/>
+            <a:ext cx="12191695" cy="777240"/>
+          </a:xfrm>
+          <a:prstGeom prst="rect">
+            <a:avLst/>
+          </a:prstGeom>
+          <a:solidFill>
+            <a:srgbClr val="0F2D52"/>
+          </a:solidFill>
+          <a:ln>
+            <a:noFill/>
+          </a:ln>
+        </p:spPr>
+        <p:style>
+          <a:lnRef idx="1">
+            <a:schemeClr val="accent1"/>
+          </a:lnRef>
+          <a:fillRef idx="3">
+            <a:schemeClr val="accent1"/>
+          </a:fillRef>
+          <a:effectRef idx="2">
+            <a:schemeClr val="accent1"/>
+          </a:effectRef>
+          <a:fontRef idx="minor">
+            <a:schemeClr val="lt1"/>
+          </a:fontRef>
+        </p:style>
+        <p:txBody>
+          <a:bodyPr rtlCol="0" anchor="ctr"/>
+          <a:lstStyle/>
+          <a:p>
+            <a:pPr algn="ctr"/>
+          </a:p>
+        </p:txBody>
+      </p:sp>
+      <p:sp>
+        <p:nvSpPr>
+          <p:cNvPr id="3" name="TextBox 2"/>
+          <p:cNvSpPr txBox="1"/>
+          <p:nvPr/>
+        </p:nvSpPr>
+        <p:spPr>
+          <a:xfrm>
+            <a:off x="457200" y="164592"/>
+            <a:ext cx="10972800" cy="502920"/>
+          </a:xfrm>
+          <a:prstGeom prst="rect">
+            <a:avLst/>
+          </a:prstGeom>
+          <a:noFill/>
+        </p:spPr>
+        <p:txBody>
+          <a:bodyPr wrap="square" lIns="45720" rIns="45720" tIns="18288" bIns="18288" anchor="ctr">
+            <a:spAutoFit/>
+          </a:bodyPr>
+          <a:lstStyle/>
+          <a:p>
+            <a:pPr algn="l"/>
+            <a:r>
+              <a:rPr sz="2400" b="1" i="0">
+                <a:solidFill>
+                  <a:srgbClr val="FFFFFF"/>
+                </a:solidFill>
+                <a:latin typeface="Calibri"/>
+              </a:rPr>
+              <a:t>📌  Cosa portare a casa</a:t>
+            </a:r>
+          </a:p>
+        </p:txBody>
+      </p:sp>
+      <p:sp>
+        <p:nvSpPr>
+          <p:cNvPr id="4" name="Oval 3"/>
+          <p:cNvSpPr/>
+          <p:nvPr/>
+        </p:nvSpPr>
+        <p:spPr>
+          <a:xfrm>
+            <a:off x="914400" y="1440180"/>
+            <a:ext cx="777240" cy="777240"/>
+          </a:xfrm>
+          <a:prstGeom prst="ellipse">
+            <a:avLst/>
+          </a:prstGeom>
+          <a:solidFill>
+            <a:srgbClr val="00A0B0"/>
+          </a:solidFill>
+          <a:ln>
+            <a:noFill/>
+          </a:ln>
+        </p:spPr>
+        <p:style>
+          <a:lnRef idx="1">
+            <a:schemeClr val="accent1"/>
+          </a:lnRef>
+          <a:fillRef idx="3">
+            <a:schemeClr val="accent1"/>
+          </a:fillRef>
+          <a:effectRef idx="2">
+            <a:schemeClr val="accent1"/>
+          </a:effectRef>
+          <a:fontRef idx="minor">
+            <a:schemeClr val="lt1"/>
+          </a:fontRef>
+        </p:style>
+        <p:txBody>
+          <a:bodyPr rtlCol="0" anchor="ctr"/>
+          <a:lstStyle/>
+          <a:p>
+            <a:pPr algn="ctr"/>
+          </a:p>
+        </p:txBody>
+      </p:sp>
+      <p:sp>
+        <p:nvSpPr>
+          <p:cNvPr id="5" name="TextBox 4"/>
+          <p:cNvSpPr txBox="1"/>
+          <p:nvPr/>
+        </p:nvSpPr>
+        <p:spPr>
+          <a:xfrm>
+            <a:off x="914400" y="1440180"/>
+            <a:ext cx="777240" cy="777240"/>
+          </a:xfrm>
+          <a:prstGeom prst="rect">
+            <a:avLst/>
+          </a:prstGeom>
+          <a:noFill/>
+        </p:spPr>
+        <p:txBody>
+          <a:bodyPr wrap="square" lIns="45720" rIns="45720" tIns="18288" bIns="18288" anchor="ctr">
+            <a:spAutoFit/>
+          </a:bodyPr>
+          <a:lstStyle/>
+          <a:p>
+            <a:pPr algn="ctr"/>
+            <a:r>
+              <a:rPr sz="2800" b="1" i="0">
+                <a:solidFill>
+                  <a:srgbClr val="FFFFFF"/>
+                </a:solidFill>
+                <a:latin typeface="Calibri"/>
+              </a:rPr>
+              <a:t>1</a:t>
+            </a:r>
+          </a:p>
+        </p:txBody>
+      </p:sp>
+      <p:sp>
+        <p:nvSpPr>
+          <p:cNvPr id="6" name="Rounded Rectangle 5"/>
+          <p:cNvSpPr/>
+          <p:nvPr/>
+        </p:nvSpPr>
+        <p:spPr>
+          <a:xfrm>
+            <a:off x="2011680" y="1440180"/>
+            <a:ext cx="9144000" cy="777240"/>
+          </a:xfrm>
+          <a:prstGeom prst="roundRect">
+            <a:avLst>
+              <a:gd name="adj" fmla="val 8000"/>
+            </a:avLst>
+          </a:prstGeom>
+          <a:solidFill>
+            <a:srgbClr val="FBFBFD"/>
+          </a:solidFill>
+          <a:ln w="19050">
+            <a:solidFill>
+              <a:srgbClr val="00A0B0"/>
+            </a:solidFill>
+          </a:ln>
+        </p:spPr>
+        <p:style>
+          <a:lnRef idx="1">
+            <a:schemeClr val="accent1"/>
+          </a:lnRef>
+          <a:fillRef idx="3">
+            <a:schemeClr val="accent1"/>
+          </a:fillRef>
+          <a:effectRef idx="2">
+            <a:schemeClr val="accent1"/>
+          </a:effectRef>
+          <a:fontRef idx="minor">
+            <a:schemeClr val="lt1"/>
+          </a:fontRef>
+        </p:style>
+        <p:txBody>
+          <a:bodyPr rtlCol="0" anchor="ctr"/>
+          <a:lstStyle/>
+          <a:p>
+            <a:pPr algn="ctr"/>
+          </a:p>
+        </p:txBody>
+      </p:sp>
+      <p:sp>
+        <p:nvSpPr>
+          <p:cNvPr id="7" name="TextBox 6"/>
+          <p:cNvSpPr txBox="1"/>
+          <p:nvPr/>
+        </p:nvSpPr>
+        <p:spPr>
+          <a:xfrm>
+            <a:off x="2286000" y="1440180"/>
+            <a:ext cx="8686800" cy="777240"/>
+          </a:xfrm>
+          <a:prstGeom prst="rect">
+            <a:avLst/>
+          </a:prstGeom>
+          <a:noFill/>
+        </p:spPr>
+        <p:txBody>
+          <a:bodyPr wrap="square" lIns="45720" rIns="45720" tIns="18288" bIns="18288" anchor="ctr">
+            <a:spAutoFit/>
+          </a:bodyPr>
+          <a:lstStyle/>
+          <a:p>
+            <a:pPr algn="l"/>
+            <a:r>
+              <a:rPr sz="1800" b="0" i="0">
+                <a:solidFill>
+                  <a:srgbClr val="1A1A2E"/>
+                </a:solidFill>
+                <a:latin typeface="Calibri"/>
+              </a:rPr>
+              <a:t>Validation, sanitization, encoding: cose DIVERSE</a:t>
+            </a:r>
+          </a:p>
+        </p:txBody>
+      </p:sp>
+      <p:sp>
+        <p:nvSpPr>
+          <p:cNvPr id="8" name="Oval 7"/>
+          <p:cNvSpPr/>
+          <p:nvPr/>
+        </p:nvSpPr>
+        <p:spPr>
+          <a:xfrm>
+            <a:off x="914400" y="2354580"/>
+            <a:ext cx="777240" cy="777240"/>
+          </a:xfrm>
+          <a:prstGeom prst="ellipse">
+            <a:avLst/>
+          </a:prstGeom>
+          <a:solidFill>
+            <a:srgbClr val="00A0B0"/>
+          </a:solidFill>
+          <a:ln>
+            <a:noFill/>
+          </a:ln>
+        </p:spPr>
+        <p:style>
+          <a:lnRef idx="1">
+            <a:schemeClr val="accent1"/>
+          </a:lnRef>
+          <a:fillRef idx="3">
+            <a:schemeClr val="accent1"/>
+          </a:fillRef>
+          <a:effectRef idx="2">
+            <a:schemeClr val="accent1"/>
+          </a:effectRef>
+          <a:fontRef idx="minor">
+            <a:schemeClr val="lt1"/>
+          </a:fontRef>
+        </p:style>
+        <p:txBody>
+          <a:bodyPr rtlCol="0" anchor="ctr"/>
+          <a:lstStyle/>
+          <a:p>
+            <a:pPr algn="ctr"/>
+          </a:p>
+        </p:txBody>
+      </p:sp>
+      <p:sp>
+        <p:nvSpPr>
+          <p:cNvPr id="9" name="TextBox 8"/>
+          <p:cNvSpPr txBox="1"/>
+          <p:nvPr/>
+        </p:nvSpPr>
+        <p:spPr>
+          <a:xfrm>
+            <a:off x="914400" y="2354580"/>
+            <a:ext cx="777240" cy="777240"/>
+          </a:xfrm>
+          <a:prstGeom prst="rect">
+            <a:avLst/>
+          </a:prstGeom>
+          <a:noFill/>
+        </p:spPr>
+        <p:txBody>
+          <a:bodyPr wrap="square" lIns="45720" rIns="45720" tIns="18288" bIns="18288" anchor="ctr">
+            <a:spAutoFit/>
+          </a:bodyPr>
+          <a:lstStyle/>
+          <a:p>
+            <a:pPr algn="ctr"/>
+            <a:r>
+              <a:rPr sz="2800" b="1" i="0">
+                <a:solidFill>
+                  <a:srgbClr val="FFFFFF"/>
+                </a:solidFill>
+                <a:latin typeface="Calibri"/>
+              </a:rPr>
+              <a:t>2</a:t>
+            </a:r>
+          </a:p>
+        </p:txBody>
+      </p:sp>
+      <p:sp>
+        <p:nvSpPr>
+          <p:cNvPr id="10" name="Rounded Rectangle 9"/>
+          <p:cNvSpPr/>
+          <p:nvPr/>
+        </p:nvSpPr>
+        <p:spPr>
+          <a:xfrm>
+            <a:off x="2011680" y="2354580"/>
+            <a:ext cx="9144000" cy="777240"/>
+          </a:xfrm>
+          <a:prstGeom prst="roundRect">
+            <a:avLst>
+              <a:gd name="adj" fmla="val 8000"/>
+            </a:avLst>
+          </a:prstGeom>
+          <a:solidFill>
+            <a:srgbClr val="FBFBFD"/>
+          </a:solidFill>
+          <a:ln w="19050">
+            <a:solidFill>
+              <a:srgbClr val="00A0B0"/>
+            </a:solidFill>
+          </a:ln>
+        </p:spPr>
+        <p:style>
+          <a:lnRef idx="1">
+            <a:schemeClr val="accent1"/>
+          </a:lnRef>
+          <a:fillRef idx="3">
+            <a:schemeClr val="accent1"/>
+          </a:fillRef>
+          <a:effectRef idx="2">
+            <a:schemeClr val="accent1"/>
+          </a:effectRef>
+          <a:fontRef idx="minor">
+            <a:schemeClr val="lt1"/>
+          </a:fontRef>
+        </p:style>
+        <p:txBody>
+          <a:bodyPr rtlCol="0" anchor="ctr"/>
+          <a:lstStyle/>
+          <a:p>
+            <a:pPr algn="ctr"/>
+          </a:p>
+        </p:txBody>
+      </p:sp>
+      <p:sp>
+        <p:nvSpPr>
+          <p:cNvPr id="11" name="TextBox 10"/>
+          <p:cNvSpPr txBox="1"/>
+          <p:nvPr/>
+        </p:nvSpPr>
+        <p:spPr>
+          <a:xfrm>
+            <a:off x="2286000" y="2354580"/>
+            <a:ext cx="8686800" cy="777240"/>
+          </a:xfrm>
+          <a:prstGeom prst="rect">
+            <a:avLst/>
+          </a:prstGeom>
+          <a:noFill/>
+        </p:spPr>
+        <p:txBody>
+          <a:bodyPr wrap="square" lIns="45720" rIns="45720" tIns="18288" bIns="18288" anchor="ctr">
+            <a:spAutoFit/>
+          </a:bodyPr>
+          <a:lstStyle/>
+          <a:p>
+            <a:pPr algn="l"/>
+            <a:r>
+              <a:rPr sz="1800" b="0" i="0">
+                <a:solidFill>
+                  <a:srgbClr val="1A1A2E"/>
+                </a:solidFill>
+                <a:latin typeface="Calibri"/>
+              </a:rPr>
+              <a:t>Whitelist sempre. Blacklist mai.</a:t>
+            </a:r>
+          </a:p>
+        </p:txBody>
+      </p:sp>
+      <p:sp>
+        <p:nvSpPr>
+          <p:cNvPr id="12" name="Oval 11"/>
+          <p:cNvSpPr/>
+          <p:nvPr/>
+        </p:nvSpPr>
+        <p:spPr>
+          <a:xfrm>
+            <a:off x="914400" y="3268980"/>
+            <a:ext cx="777240" cy="777240"/>
+          </a:xfrm>
+          <a:prstGeom prst="ellipse">
+            <a:avLst/>
+          </a:prstGeom>
+          <a:solidFill>
+            <a:srgbClr val="00A0B0"/>
+          </a:solidFill>
+          <a:ln>
+            <a:noFill/>
+          </a:ln>
+        </p:spPr>
+        <p:style>
+          <a:lnRef idx="1">
+            <a:schemeClr val="accent1"/>
+          </a:lnRef>
+          <a:fillRef idx="3">
+            <a:schemeClr val="accent1"/>
+          </a:fillRef>
+          <a:effectRef idx="2">
+            <a:schemeClr val="accent1"/>
+          </a:effectRef>
+          <a:fontRef idx="minor">
+            <a:schemeClr val="lt1"/>
+          </a:fontRef>
+        </p:style>
+        <p:txBody>
+          <a:bodyPr rtlCol="0" anchor="ctr"/>
+          <a:lstStyle/>
+          <a:p>
+            <a:pPr algn="ctr"/>
+          </a:p>
+        </p:txBody>
+      </p:sp>
+      <p:sp>
+        <p:nvSpPr>
+          <p:cNvPr id="13" name="TextBox 12"/>
+          <p:cNvSpPr txBox="1"/>
+          <p:nvPr/>
+        </p:nvSpPr>
+        <p:spPr>
+          <a:xfrm>
+            <a:off x="914400" y="3268980"/>
+            <a:ext cx="777240" cy="777240"/>
+          </a:xfrm>
+          <a:prstGeom prst="rect">
+            <a:avLst/>
+          </a:prstGeom>
+          <a:noFill/>
+        </p:spPr>
+        <p:txBody>
+          <a:bodyPr wrap="square" lIns="45720" rIns="45720" tIns="18288" bIns="18288" anchor="ctr">
+            <a:spAutoFit/>
+          </a:bodyPr>
+          <a:lstStyle/>
+          <a:p>
+            <a:pPr algn="ctr"/>
+            <a:r>
+              <a:rPr sz="2800" b="1" i="0">
+                <a:solidFill>
+                  <a:srgbClr val="FFFFFF"/>
+                </a:solidFill>
+                <a:latin typeface="Calibri"/>
+              </a:rPr>
+              <a:t>3</a:t>
+            </a:r>
+          </a:p>
+        </p:txBody>
+      </p:sp>
+      <p:sp>
+        <p:nvSpPr>
+          <p:cNvPr id="14" name="Rounded Rectangle 13"/>
+          <p:cNvSpPr/>
+          <p:nvPr/>
+        </p:nvSpPr>
+        <p:spPr>
+          <a:xfrm>
+            <a:off x="2011680" y="3268980"/>
+            <a:ext cx="9144000" cy="777240"/>
+          </a:xfrm>
+          <a:prstGeom prst="roundRect">
+            <a:avLst>
+              <a:gd name="adj" fmla="val 8000"/>
+            </a:avLst>
+          </a:prstGeom>
+          <a:solidFill>
+            <a:srgbClr val="FBFBFD"/>
+          </a:solidFill>
+          <a:ln w="19050">
+            <a:solidFill>
+              <a:srgbClr val="00A0B0"/>
+            </a:solidFill>
+          </a:ln>
+        </p:spPr>
+        <p:style>
+          <a:lnRef idx="1">
+            <a:schemeClr val="accent1"/>
+          </a:lnRef>
+          <a:fillRef idx="3">
+            <a:schemeClr val="accent1"/>
+          </a:fillRef>
+          <a:effectRef idx="2">
+            <a:schemeClr val="accent1"/>
+          </a:effectRef>
+          <a:fontRef idx="minor">
+            <a:schemeClr val="lt1"/>
+          </a:fontRef>
+        </p:style>
+        <p:txBody>
+          <a:bodyPr rtlCol="0" anchor="ctr"/>
+          <a:lstStyle/>
+          <a:p>
+            <a:pPr algn="ctr"/>
+          </a:p>
+        </p:txBody>
+      </p:sp>
+      <p:sp>
+        <p:nvSpPr>
+          <p:cNvPr id="15" name="TextBox 14"/>
+          <p:cNvSpPr txBox="1"/>
+          <p:nvPr/>
+        </p:nvSpPr>
+        <p:spPr>
+          <a:xfrm>
+            <a:off x="2286000" y="3268980"/>
+            <a:ext cx="8686800" cy="777240"/>
+          </a:xfrm>
+          <a:prstGeom prst="rect">
+            <a:avLst/>
+          </a:prstGeom>
+          <a:noFill/>
+        </p:spPr>
+        <p:txBody>
+          <a:bodyPr wrap="square" lIns="45720" rIns="45720" tIns="18288" bIns="18288" anchor="ctr">
+            <a:spAutoFit/>
+          </a:bodyPr>
+          <a:lstStyle/>
+          <a:p>
+            <a:pPr algn="l"/>
+            <a:r>
+              <a:rPr sz="1800" b="0" i="0">
+                <a:solidFill>
+                  <a:srgbClr val="1A1A2E"/>
+                </a:solidFill>
+                <a:latin typeface="Calibri"/>
+              </a:rPr>
+              <a:t>Pydantic per validation strutturata in Python</a:t>
+            </a:r>
+          </a:p>
+        </p:txBody>
+      </p:sp>
+      <p:sp>
+        <p:nvSpPr>
+          <p:cNvPr id="16" name="Oval 15"/>
+          <p:cNvSpPr/>
+          <p:nvPr/>
+        </p:nvSpPr>
+        <p:spPr>
+          <a:xfrm>
+            <a:off x="914400" y="4183380"/>
+            <a:ext cx="777240" cy="777240"/>
+          </a:xfrm>
+          <a:prstGeom prst="ellipse">
+            <a:avLst/>
+          </a:prstGeom>
+          <a:solidFill>
+            <a:srgbClr val="00A0B0"/>
+          </a:solidFill>
+          <a:ln>
+            <a:noFill/>
+          </a:ln>
+        </p:spPr>
+        <p:style>
+          <a:lnRef idx="1">
+            <a:schemeClr val="accent1"/>
+          </a:lnRef>
+          <a:fillRef idx="3">
+            <a:schemeClr val="accent1"/>
+          </a:fillRef>
+          <a:effectRef idx="2">
+            <a:schemeClr val="accent1"/>
+          </a:effectRef>
+          <a:fontRef idx="minor">
+            <a:schemeClr val="lt1"/>
+          </a:fontRef>
+        </p:style>
+        <p:txBody>
+          <a:bodyPr rtlCol="0" anchor="ctr"/>
+          <a:lstStyle/>
+          <a:p>
+            <a:pPr algn="ctr"/>
+          </a:p>
+        </p:txBody>
+      </p:sp>
+      <p:sp>
+        <p:nvSpPr>
+          <p:cNvPr id="17" name="TextBox 16"/>
+          <p:cNvSpPr txBox="1"/>
+          <p:nvPr/>
+        </p:nvSpPr>
+        <p:spPr>
+          <a:xfrm>
+            <a:off x="914400" y="4183380"/>
+            <a:ext cx="777240" cy="777240"/>
+          </a:xfrm>
+          <a:prstGeom prst="rect">
+            <a:avLst/>
+          </a:prstGeom>
+          <a:noFill/>
+        </p:spPr>
+        <p:txBody>
+          <a:bodyPr wrap="square" lIns="45720" rIns="45720" tIns="18288" bIns="18288" anchor="ctr">
+            <a:spAutoFit/>
+          </a:bodyPr>
+          <a:lstStyle/>
+          <a:p>
+            <a:pPr algn="ctr"/>
+            <a:r>
+              <a:rPr sz="2800" b="1" i="0">
+                <a:solidFill>
+                  <a:srgbClr val="FFFFFF"/>
+                </a:solidFill>
+                <a:latin typeface="Calibri"/>
+              </a:rPr>
+              <a:t>4</a:t>
+            </a:r>
+          </a:p>
+        </p:txBody>
+      </p:sp>
+      <p:sp>
+        <p:nvSpPr>
+          <p:cNvPr id="18" name="Rounded Rectangle 17"/>
+          <p:cNvSpPr/>
+          <p:nvPr/>
+        </p:nvSpPr>
+        <p:spPr>
+          <a:xfrm>
+            <a:off x="2011680" y="4183380"/>
+            <a:ext cx="9144000" cy="777240"/>
+          </a:xfrm>
+          <a:prstGeom prst="roundRect">
+            <a:avLst>
+              <a:gd name="adj" fmla="val 8000"/>
+            </a:avLst>
+          </a:prstGeom>
+          <a:solidFill>
+            <a:srgbClr val="FBFBFD"/>
+          </a:solidFill>
+          <a:ln w="19050">
+            <a:solidFill>
+              <a:srgbClr val="00A0B0"/>
+            </a:solidFill>
+          </a:ln>
+        </p:spPr>
+        <p:style>
+          <a:lnRef idx="1">
+            <a:schemeClr val="accent1"/>
+          </a:lnRef>
+          <a:fillRef idx="3">
+            <a:schemeClr val="accent1"/>
+          </a:fillRef>
+          <a:effectRef idx="2">
+            <a:schemeClr val="accent1"/>
+          </a:effectRef>
+          <a:fontRef idx="minor">
+            <a:schemeClr val="lt1"/>
+          </a:fontRef>
+        </p:style>
+        <p:txBody>
+          <a:bodyPr rtlCol="0" anchor="ctr"/>
+          <a:lstStyle/>
+          <a:p>
+            <a:pPr algn="ctr"/>
+          </a:p>
+        </p:txBody>
+      </p:sp>
+      <p:sp>
+        <p:nvSpPr>
+          <p:cNvPr id="19" name="TextBox 18"/>
+          <p:cNvSpPr txBox="1"/>
+          <p:nvPr/>
+        </p:nvSpPr>
+        <p:spPr>
+          <a:xfrm>
+            <a:off x="2286000" y="4183380"/>
+            <a:ext cx="8686800" cy="777240"/>
+          </a:xfrm>
+          <a:prstGeom prst="rect">
+            <a:avLst/>
+          </a:prstGeom>
+          <a:noFill/>
+        </p:spPr>
+        <p:txBody>
+          <a:bodyPr wrap="square" lIns="45720" rIns="45720" tIns="18288" bIns="18288" anchor="ctr">
+            <a:spAutoFit/>
+          </a:bodyPr>
+          <a:lstStyle/>
+          <a:p>
+            <a:pPr algn="l"/>
+            <a:r>
+              <a:rPr sz="1800" b="0" i="0">
+                <a:solidFill>
+                  <a:srgbClr val="1A1A2E"/>
+                </a:solidFill>
+                <a:latin typeface="Calibri"/>
+              </a:rPr>
+              <a:t>Path traversal: 3 controlli obbligatori (whitelist, ext, realpath)</a:t>
+            </a:r>
+          </a:p>
+        </p:txBody>
+      </p:sp>
+      <p:sp>
+        <p:nvSpPr>
+          <p:cNvPr id="20" name="Oval 19"/>
+          <p:cNvSpPr/>
+          <p:nvPr/>
+        </p:nvSpPr>
+        <p:spPr>
+          <a:xfrm>
+            <a:off x="914400" y="5097780"/>
+            <a:ext cx="777240" cy="777240"/>
+          </a:xfrm>
+          <a:prstGeom prst="ellipse">
+            <a:avLst/>
+          </a:prstGeom>
+          <a:solidFill>
+            <a:srgbClr val="00A0B0"/>
+          </a:solidFill>
+          <a:ln>
+            <a:noFill/>
+          </a:ln>
+        </p:spPr>
+        <p:style>
+          <a:lnRef idx="1">
+            <a:schemeClr val="accent1"/>
+          </a:lnRef>
+          <a:fillRef idx="3">
+            <a:schemeClr val="accent1"/>
+          </a:fillRef>
+          <a:effectRef idx="2">
+            <a:schemeClr val="accent1"/>
+          </a:effectRef>
+          <a:fontRef idx="minor">
+            <a:schemeClr val="lt1"/>
+          </a:fontRef>
+        </p:style>
+        <p:txBody>
+          <a:bodyPr rtlCol="0" anchor="ctr"/>
+          <a:lstStyle/>
+          <a:p>
+            <a:pPr algn="ctr"/>
+          </a:p>
+        </p:txBody>
+      </p:sp>
+      <p:sp>
+        <p:nvSpPr>
+          <p:cNvPr id="21" name="TextBox 20"/>
+          <p:cNvSpPr txBox="1"/>
+          <p:nvPr/>
+        </p:nvSpPr>
+        <p:spPr>
+          <a:xfrm>
+            <a:off x="914400" y="5097780"/>
+            <a:ext cx="777240" cy="777240"/>
+          </a:xfrm>
+          <a:prstGeom prst="rect">
+            <a:avLst/>
+          </a:prstGeom>
+          <a:noFill/>
+        </p:spPr>
+        <p:txBody>
+          <a:bodyPr wrap="square" lIns="45720" rIns="45720" tIns="18288" bIns="18288" anchor="ctr">
+            <a:spAutoFit/>
+          </a:bodyPr>
+          <a:lstStyle/>
+          <a:p>
+            <a:pPr algn="ctr"/>
+            <a:r>
+              <a:rPr sz="2800" b="1" i="0">
+                <a:solidFill>
+                  <a:srgbClr val="FFFFFF"/>
+                </a:solidFill>
+                <a:latin typeface="Calibri"/>
+              </a:rPr>
+              <a:t>5</a:t>
+            </a:r>
+          </a:p>
+        </p:txBody>
+      </p:sp>
+      <p:sp>
+        <p:nvSpPr>
+          <p:cNvPr id="22" name="Rounded Rectangle 21"/>
+          <p:cNvSpPr/>
+          <p:nvPr/>
+        </p:nvSpPr>
+        <p:spPr>
+          <a:xfrm>
+            <a:off x="2011680" y="5097780"/>
+            <a:ext cx="9144000" cy="777240"/>
+          </a:xfrm>
+          <a:prstGeom prst="roundRect">
+            <a:avLst>
+              <a:gd name="adj" fmla="val 8000"/>
+            </a:avLst>
+          </a:prstGeom>
+          <a:solidFill>
+            <a:srgbClr val="FBFBFD"/>
+          </a:solidFill>
+          <a:ln w="19050">
+            <a:solidFill>
+              <a:srgbClr val="00A0B0"/>
+            </a:solidFill>
+          </a:ln>
+        </p:spPr>
+        <p:style>
+          <a:lnRef idx="1">
+            <a:schemeClr val="accent1"/>
+          </a:lnRef>
+          <a:fillRef idx="3">
+            <a:schemeClr val="accent1"/>
+          </a:fillRef>
+          <a:effectRef idx="2">
+            <a:schemeClr val="accent1"/>
+          </a:effectRef>
+          <a:fontRef idx="minor">
+            <a:schemeClr val="lt1"/>
+          </a:fontRef>
+        </p:style>
+        <p:txBody>
+          <a:bodyPr rtlCol="0" anchor="ctr"/>
+          <a:lstStyle/>
+          <a:p>
+            <a:pPr algn="ctr"/>
+          </a:p>
+        </p:txBody>
+      </p:sp>
+      <p:sp>
+        <p:nvSpPr>
+          <p:cNvPr id="23" name="TextBox 22"/>
+          <p:cNvSpPr txBox="1"/>
+          <p:nvPr/>
+        </p:nvSpPr>
+        <p:spPr>
+          <a:xfrm>
+            <a:off x="2286000" y="5097780"/>
+            <a:ext cx="8686800" cy="777240"/>
+          </a:xfrm>
+          <a:prstGeom prst="rect">
+            <a:avLst/>
+          </a:prstGeom>
+          <a:noFill/>
+        </p:spPr>
+        <p:txBody>
+          <a:bodyPr wrap="square" lIns="45720" rIns="45720" tIns="18288" bIns="18288" anchor="ctr">
+            <a:spAutoFit/>
+          </a:bodyPr>
+          <a:lstStyle/>
+          <a:p>
+            <a:pPr algn="l"/>
+            <a:r>
+              <a:rPr sz="1800" b="0" i="0">
+                <a:solidFill>
+                  <a:srgbClr val="1A1A2E"/>
+                </a:solidFill>
+                <a:latin typeface="Calibri"/>
+              </a:rPr>
+              <a:t>pip-audit + SBOM obbligatori dal 2027 (CRA)</a:t>
+            </a:r>
+          </a:p>
+        </p:txBody>
+      </p:sp>
+      <p:cxnSp>
+        <p:nvCxnSpPr>
+          <p:cNvPr id="24" name="Connector 23"/>
+          <p:cNvCxnSpPr/>
+          <p:nvPr/>
+        </p:nvCxnSpPr>
+        <p:spPr>
+          <a:xfrm>
+            <a:off x="457200" y="6446520"/>
+            <a:ext cx="11274552" cy="0"/>
+          </a:xfrm>
+          <a:prstGeom prst="line">
+            <a:avLst/>
+          </a:prstGeom>
+          <a:ln w="19050">
+            <a:solidFill>
+              <a:srgbClr val="00A0B0"/>
+            </a:solidFill>
+          </a:ln>
+        </p:spPr>
+        <p:style>
+          <a:lnRef idx="2">
+            <a:schemeClr val="accent1"/>
+          </a:lnRef>
+          <a:fillRef idx="0">
+            <a:schemeClr val="accent1"/>
+          </a:fillRef>
+          <a:effectRef idx="1">
+            <a:schemeClr val="accent1"/>
+          </a:effectRef>
+          <a:fontRef idx="minor">
+            <a:schemeClr val="tx1"/>
+          </a:fontRef>
+        </p:style>
+      </p:cxnSp>
+      <p:sp>
+        <p:nvSpPr>
+          <p:cNvPr id="25" name="TextBox 24"/>
+          <p:cNvSpPr txBox="1"/>
+          <p:nvPr/>
+        </p:nvSpPr>
+        <p:spPr>
+          <a:xfrm>
+            <a:off x="457200" y="6473952"/>
+            <a:ext cx="7315200" cy="292608"/>
+          </a:xfrm>
+          <a:prstGeom prst="rect">
+            <a:avLst/>
+          </a:prstGeom>
+          <a:noFill/>
+        </p:spPr>
+        <p:txBody>
+          <a:bodyPr wrap="square" lIns="45720" rIns="45720" tIns="18288" bIns="18288" anchor="t">
+            <a:spAutoFit/>
+          </a:bodyPr>
+          <a:lstStyle/>
+          <a:p>
+            <a:pPr algn="l"/>
+            <a:r>
+              <a:rPr sz="1000" b="0" i="0">
+                <a:solidFill>
+                  <a:srgbClr val="6B7280"/>
+                </a:solidFill>
+                <a:latin typeface="Calibri"/>
+              </a:rPr>
+              <a:t>Secure Coding · Corso IFTS STEM · A. Manneschi · 2024/2025</a:t>
+            </a:r>
+          </a:p>
+        </p:txBody>
+      </p:sp>
+      <p:sp>
+        <p:nvSpPr>
+          <p:cNvPr id="26" name="TextBox 25"/>
+          <p:cNvSpPr txBox="1"/>
+          <p:nvPr/>
+        </p:nvSpPr>
+        <p:spPr>
+          <a:xfrm>
+            <a:off x="10515600" y="6473952"/>
+            <a:ext cx="1188720" cy="292608"/>
+          </a:xfrm>
+          <a:prstGeom prst="rect">
+            <a:avLst/>
+          </a:prstGeom>
+          <a:noFill/>
+        </p:spPr>
+        <p:txBody>
+          <a:bodyPr wrap="square" lIns="45720" rIns="45720" tIns="18288" bIns="18288" anchor="t">
+            <a:spAutoFit/>
+          </a:bodyPr>
+          <a:lstStyle/>
+          <a:p>
+            <a:pPr algn="r"/>
+            <a:r>
+              <a:rPr sz="1000" b="1" i="0">
+                <a:solidFill>
+                  <a:srgbClr val="6B7280"/>
+                </a:solidFill>
+                <a:latin typeface="Calibri"/>
+              </a:rPr>
+              <a:t>L6  ·  14/15</a:t>
+            </a:r>
+          </a:p>
+        </p:txBody>
+      </p:sp>
+    </p:spTree>
+  </p:cSld>
+  <p:clrMapOvr>
+    <a:masterClrMapping/>
+  </p:clrMapOvr>
+</p:sld>
+</file>
+
+<file path=ppt/slides/slide15.xml><?xml version="1.0" encoding="utf-8"?>
+<p:sld xmlns:a="http://schemas.openxmlformats.org/drawingml/2006/main" xmlns:p="http://schemas.openxmlformats.org/presentationml/2006/main" xmlns:r="http://schemas.openxmlformats.org/officeDocument/2006/relationships">
+  <p:cSld>
+    <p:spTree>
+      <p:nvGrpSpPr>
+        <p:cNvPr id="1" name=""/>
+        <p:cNvGrpSpPr/>
+        <p:nvPr/>
+      </p:nvGrpSpPr>
+      <p:grpSpPr/>
+      <p:sp>
+        <p:nvSpPr>
+          <p:cNvPr id="2" name="Rectangle 1"/>
+          <p:cNvSpPr/>
+          <p:nvPr/>
+        </p:nvSpPr>
+        <p:spPr>
+          <a:xfrm>
+            <a:off x="0" y="0"/>
             <a:ext cx="12191695" cy="6858000"/>
           </a:xfrm>
           <a:prstGeom prst="rect">
@@ -6155,7 +6723,7 @@
                 </a:solidFill>
                 <a:latin typeface="Calibri"/>
               </a:rPr>
-              <a:t>L6  ·  14/14</a:t>
+              <a:t>L6  ·  15/15</a:t>
             </a:r>
           </a:p>
         </p:txBody>
@@ -7104,7 +7672,7 @@
                 </a:solidFill>
                 <a:latin typeface="Calibri"/>
               </a:rPr>
-              <a:t>L6  ·  2/14</a:t>
+              <a:t>L6  ·  2/15</a:t>
             </a:r>
           </a:p>
         </p:txBody>
@@ -7607,7 +8175,7 @@
                 </a:solidFill>
                 <a:latin typeface="Calibri"/>
               </a:rPr>
-              <a:t>L6  ·  3/14</a:t>
+              <a:t>L6  ·  3/15</a:t>
             </a:r>
           </a:p>
         </p:txBody>
@@ -8668,7 +9236,7 @@
                 </a:solidFill>
                 <a:latin typeface="Calibri"/>
               </a:rPr>
-              <a:t>L6  ·  4/14</a:t>
+              <a:t>L6  ·  4/15</a:t>
             </a:r>
           </a:p>
         </p:txBody>
@@ -9060,7 +9628,7 @@
                 </a:solidFill>
                 <a:latin typeface="Calibri"/>
               </a:rPr>
-              <a:t>L6  ·  5/14</a:t>
+              <a:t>L6  ·  5/15</a:t>
             </a:r>
           </a:p>
         </p:txBody>
@@ -9320,7 +9888,7 @@
                 </a:solidFill>
                 <a:latin typeface="Calibri"/>
               </a:rPr>
-              <a:t>L6  ·  6/14</a:t>
+              <a:t>L6  ·  6/15</a:t>
             </a:r>
           </a:p>
         </p:txBody>
@@ -9712,7 +10280,7 @@
                 </a:solidFill>
                 <a:latin typeface="Calibri"/>
               </a:rPr>
-              <a:t>L6  ·  7/14</a:t>
+              <a:t>L6  ·  7/15</a:t>
             </a:r>
           </a:p>
         </p:txBody>
@@ -10901,7 +11469,7 @@
                 </a:solidFill>
                 <a:latin typeface="Calibri"/>
               </a:rPr>
-              <a:t>L6  ·  8/14</a:t>
+              <a:t>L6  ·  8/15</a:t>
             </a:r>
           </a:p>
         </p:txBody>
@@ -12356,7 +12924,7 @@
                 </a:solidFill>
                 <a:latin typeface="Calibri"/>
               </a:rPr>
-              <a:t>L6  ·  9/14</a:t>
+              <a:t>L6  ·  9/15</a:t>
             </a:r>
           </a:p>
         </p:txBody>

</xml_diff>